<commit_message>
docs: update references for Grafana operations dashboards
</commit_message>
<xml_diff>
--- a/output/presentation/Thailand-Regional-Banking-Intelligence.pptx
+++ b/output/presentation/Thailand-Regional-Banking-Intelligence.pptx
@@ -130,14 +130,14 @@
   <p:extLst>
     <p:ext uri="{521415D9-36F7-43E2-AB2F-B90AF26B5E84}">
       <p14:sectionLst xmlns:p14="http://schemas.microsoft.com/office/powerpoint/2010/main">
-        <p14:section name="Introduction" id="{d0f9adc4-17e1-b7dc-330e-3d7bb6a0ce13}">
+        <p14:section name="Introduction" id="{d9106ada-c01b-d5f6-7e25-c212fd97e1ca}">
           <p14:sldIdLst>
             <p14:sldId id="256"/>
             <p14:sldId id="257"/>
             <p14:sldId id="258"/>
           </p14:sldIdLst>
         </p14:section>
-        <p14:section name="Data &amp; Architecture" id="{9d7bd144-8e56-41d0-a646-13c6b95422ae}">
+        <p14:section name="Data &amp; Architecture" id="{bb499f42-c462-1ae6-5ac6-535793ab81c5}">
           <p14:sldIdLst>
             <p14:sldId id="259"/>
             <p14:sldId id="260"/>
@@ -145,7 +145,7 @@
             <p14:sldId id="262"/>
           </p14:sldIdLst>
         </p14:section>
-        <p14:section name="Findings" id="{ac513326-ecc9-6948-20e5-e1cbbafd3696}">
+        <p14:section name="Findings" id="{bffeb024-dff4-bb26-5aa5-66da5223d1ec}">
           <p14:sldIdLst>
             <p14:sldId id="263"/>
             <p14:sldId id="264"/>
@@ -153,20 +153,20 @@
             <p14:sldId id="266"/>
           </p14:sldIdLst>
         </p14:section>
-        <p14:section name="Application" id="{638d8f4e-697f-8651-6b1e-a03d55f2c615}">
+        <p14:section name="Application" id="{072b2220-def9-2f1d-ede8-6788e9594f24}">
           <p14:sldIdLst>
             <p14:sldId id="267"/>
             <p14:sldId id="268"/>
           </p14:sldIdLst>
         </p14:section>
-        <p14:section name="Validation &amp; Next steps" id="{03d066fe-a7b3-821b-478b-8b072ebec374}">
+        <p14:section name="Validation &amp; Next steps" id="{6e172f6c-6411-481f-21f8-9016bb3d573a}">
           <p14:sldIdLst>
             <p14:sldId id="269"/>
             <p14:sldId id="270"/>
             <p14:sldId id="271"/>
           </p14:sldIdLst>
         </p14:section>
-        <p14:section name="Appendix" id="{b32d6457-cc0b-19a2-e0de-1f1ae3e6e7bb}">
+        <p14:section name="Appendix" id="{d26912e1-0c75-b567-52f6-5fca0e5a063c}">
           <p14:sldIdLst>
             <p14:sldId id="272"/>
             <p14:sldId id="273"/>
@@ -4826,7 +4826,7 @@
           <a:p>
             <a:r>
               <a:rPr lang="en-US" dirty="0"/>
-              <a:t>ไล่จากซ้ายไปขวา: ETL ใน Python ตรวจ schema และหน่วยก่อนเขียนลง PostgreSQL, Airflow ตั้งเวลา 07:00 ทุกวัน, FastAPI เป็นชั้นเดียวที่แตะฐานข้อมูลแบบอ่านอย่างเดียว ส่วน Next.js เรียกผ่าน server proxy และ Grafana ใช้สำหรับรายงาน</a:t>
+              <a:t>ไล่จากซ้ายไปขวา: ETL ใน Python ตรวจ schema และหน่วยก่อนเขียนลง PostgreSQL, Airflow ตั้งเวลา 07:00 ทุกวัน, FastAPI เป็นชั้นเดียวที่แตะฐานข้อมูลแบบอ่านอย่างเดียว ส่วน Next.js เรียกผ่าน server proxy และ Grafana ใช้ติดตามสถานะ pipeline คุณภาพข้อมูล และ AI/API</a:t>
             </a:r>
             <a:endParaRPr lang="en-US" dirty="0"/>
           </a:p>
@@ -27678,7 +27678,7 @@
                   <a:schemeClr val="accent4"/>
                 </a:solidFill>
               </a:rPr>
-              <a:t>13 Grafana panels</a:t>
+              <a:t>Grafana ops monitoring</a:t>
             </a:r>
             <a:endParaRPr lang="en-US" sz="1200" dirty="0"/>
           </a:p>
@@ -28987,7 +28987,7 @@
         <a:srgbClr val="14264A"/>
       </a:folHlink>
     </a:clrScheme>
-    <a:fontScheme name="Bank Intelligence">
+    <a:fontScheme name="Office">
       <a:majorFont>
         <a:latin typeface="Leelawadee UI"/>
         <a:ea typeface=""/>

</xml_diff>